<commit_message>
Update URL reference system and documentation
- Add comprehensive URL_REFERENCE_SYSTEM.md with verified platform URLs
- Update MONITOR_AND_REPORT.ps1 with URL verification table in daily health check email
- Correct URL documentation discrepancies across multiple README files
- Add QUICK_START_MASTER_GUIDE.md for service management reference
- Update various platform documentation and data files
- Remove obsolete vpn_retry_tracker.json file
</commit_message>
<xml_diff>
--- a/Store Support/Projects/TDA Insights/TDA_WK13_Report.pptx
+++ b/Store Support/Projects/TDA Insights/TDA_WK13_Report.pptx
@@ -22,6 +22,7 @@
     <p:sldId id="270" r:id="rId21"/>
     <p:sldId id="271" r:id="rId22"/>
     <p:sldId id="272" r:id="rId23"/>
+    <p:sldId id="273" r:id="rId24"/>
   </p:sldIdLst>
   <p:sldSz cx="9144000" cy="6858000" type="screen4x3"/>
   <p:notesSz cx="6858000" cy="9144000"/>
@@ -3388,7 +3389,7 @@
         <p:spPr>
           <a:xfrm>
             <a:off x="0" y="0"/>
-            <a:ext cx="9144000" cy="6858000"/>
+            <a:ext cx="9144000" cy="6615324"/>
           </a:xfrm>
           <a:prstGeom prst="rect">
             <a:avLst/>
@@ -3430,7 +3431,7 @@
         <p:spPr>
           <a:xfrm>
             <a:off x="0" y="0"/>
-            <a:ext cx="9144000" cy="2334535"/>
+            <a:ext cx="9144000" cy="6858000"/>
           </a:xfrm>
           <a:prstGeom prst="rect">
             <a:avLst/>
@@ -3472,7 +3473,7 @@
         <p:spPr>
           <a:xfrm>
             <a:off x="0" y="0"/>
-            <a:ext cx="9144000" cy="6858000"/>
+            <a:ext cx="9144000" cy="3795439"/>
           </a:xfrm>
           <a:prstGeom prst="rect">
             <a:avLst/>
@@ -3572,6 +3573,48 @@
 </file>
 
 <file path=ppt/slides/slide17.xml><?xml version="1.0" encoding="utf-8"?>
+<p:sld xmlns:a="http://schemas.openxmlformats.org/drawingml/2006/main" xmlns:p="http://schemas.openxmlformats.org/presentationml/2006/main" xmlns:r="http://schemas.openxmlformats.org/officeDocument/2006/relationships">
+  <p:cSld>
+    <p:spTree>
+      <p:nvGrpSpPr>
+        <p:cNvPr id="1" name=""/>
+        <p:cNvGrpSpPr/>
+        <p:nvPr/>
+      </p:nvGrpSpPr>
+      <p:grpSpPr/>
+      <p:pic>
+        <p:nvPicPr>
+          <p:cNvPr id="2" name="Picture 1" descr="image.jpg"/>
+          <p:cNvPicPr>
+            <a:picLocks noChangeAspect="1"/>
+          </p:cNvPicPr>
+          <p:nvPr/>
+        </p:nvPicPr>
+        <p:blipFill>
+          <a:blip r:embed="rId2"/>
+          <a:stretch>
+            <a:fillRect/>
+          </a:stretch>
+        </p:blipFill>
+        <p:spPr>
+          <a:xfrm>
+            <a:off x="0" y="0"/>
+            <a:ext cx="9144000" cy="6858000"/>
+          </a:xfrm>
+          <a:prstGeom prst="rect">
+            <a:avLst/>
+          </a:prstGeom>
+        </p:spPr>
+      </p:pic>
+    </p:spTree>
+  </p:cSld>
+  <p:clrMapOvr>
+    <a:masterClrMapping/>
+  </p:clrMapOvr>
+</p:sld>
+</file>
+
+<file path=ppt/slides/slide18.xml><?xml version="1.0" encoding="utf-8"?>
 <p:sld xmlns:a="http://schemas.openxmlformats.org/drawingml/2006/main" xmlns:p="http://schemas.openxmlformats.org/presentationml/2006/main" xmlns:r="http://schemas.openxmlformats.org/officeDocument/2006/relationships">
   <p:cSld>
     <p:spTree>
@@ -3850,7 +3893,7 @@
         <p:spPr>
           <a:xfrm>
             <a:off x="0" y="0"/>
-            <a:ext cx="9144000" cy="6445452"/>
+            <a:ext cx="9144000" cy="6547375"/>
           </a:xfrm>
           <a:prstGeom prst="rect">
             <a:avLst/>

</xml_diff>